<commit_message>
Eliminar archivos obsoletos y actualizar la estructura del proyecto: se eliminan archivos de configuración y scripts no utilizados, se agrega un nuevo script de inicio y se mejora la documentación de las presentaciones.
</commit_message>
<xml_diff>
--- a/PLANTILLA_FSC.pptx
+++ b/PLANTILLA_FSC.pptx
@@ -107,6 +107,11 @@
       </a:defRPr>
     </a:lvl9pPr>
   </p:defaultTextStyle>
+  <p:extLst>
+    <p:ext uri="{EFAFB233-063F-42B5-8137-9DF3F51BA10A}">
+      <p15:sldGuideLst xmlns:p15="http://schemas.microsoft.com/office/powerpoint/2012/main"/>
+    </p:ext>
+  </p:extLst>
 </p:presentation>
 </file>
 
@@ -1167,63 +1172,8 @@
         </p:nvSpPr>
         <p:spPr>
           <a:xfrm>
-            <a:off x="1901170" y="3982638"/>
-            <a:ext cx="3745486" cy="658813"/>
-          </a:xfrm>
-        </p:spPr>
-        <p:txBody>
-          <a:bodyPr anchor="ctr"/>
-          <a:lstStyle>
-            <a:lvl1pPr>
-              <a:buNone/>
-              <a:defRPr/>
-            </a:lvl1pPr>
-            <a:lvl2pPr>
-              <a:buNone/>
-              <a:defRPr/>
-            </a:lvl2pPr>
-            <a:lvl3pPr>
-              <a:buNone/>
-              <a:defRPr/>
-            </a:lvl3pPr>
-            <a:lvl4pPr>
-              <a:buNone/>
-              <a:defRPr/>
-            </a:lvl4pPr>
-            <a:lvl5pPr>
-              <a:buNone/>
-              <a:defRPr/>
-            </a:lvl5pPr>
-          </a:lstStyle>
-          <a:p>
-            <a:pPr lvl="0"/>
-            <a:r>
-              <a:rPr lang="es-CL" dirty="0"/>
-              <a:t>{{UNIDAD}}</a:t>
-            </a:r>
-          </a:p>
-        </p:txBody>
-      </p:sp>
-      <p:sp>
-        <p:nvSpPr>
-          <p:cNvPr id="15" name="Marcador de texto 13">
-            <a:extLst>
-              <a:ext uri="{FF2B5EF4-FFF2-40B4-BE49-F238E27FC236}">
-                <a16:creationId xmlns:a16="http://schemas.microsoft.com/office/drawing/2014/main" id="{25726873-305B-2BD9-5572-EA6B4B8E3D3F}"/>
-              </a:ext>
-            </a:extLst>
-          </p:cNvPr>
-          <p:cNvSpPr>
-            <a:spLocks noGrp="1"/>
-          </p:cNvSpPr>
-          <p:nvPr>
-            <p:ph type="body" sz="quarter" idx="11" hasCustomPrompt="1"/>
-          </p:nvPr>
-        </p:nvSpPr>
-        <p:spPr>
-          <a:xfrm>
-            <a:off x="1901170" y="4785488"/>
-            <a:ext cx="3745486" cy="380402"/>
+            <a:off x="2125842" y="3769654"/>
+            <a:ext cx="4716918" cy="658813"/>
           </a:xfrm>
         </p:spPr>
         <p:txBody>
@@ -1233,6 +1183,63 @@
           <a:lstStyle>
             <a:lvl1pPr>
               <a:buNone/>
+              <a:defRPr sz="3200" b="1"/>
+            </a:lvl1pPr>
+            <a:lvl2pPr>
+              <a:buNone/>
+              <a:defRPr/>
+            </a:lvl2pPr>
+            <a:lvl3pPr>
+              <a:buNone/>
+              <a:defRPr/>
+            </a:lvl3pPr>
+            <a:lvl4pPr>
+              <a:buNone/>
+              <a:defRPr/>
+            </a:lvl4pPr>
+            <a:lvl5pPr>
+              <a:buNone/>
+              <a:defRPr/>
+            </a:lvl5pPr>
+          </a:lstStyle>
+          <a:p>
+            <a:pPr lvl="0"/>
+            <a:r>
+              <a:rPr lang="es-CL" dirty="0"/>
+              <a:t>{{UNIDAD}}</a:t>
+            </a:r>
+          </a:p>
+        </p:txBody>
+      </p:sp>
+      <p:sp>
+        <p:nvSpPr>
+          <p:cNvPr id="15" name="Marcador de texto 13">
+            <a:extLst>
+              <a:ext uri="{FF2B5EF4-FFF2-40B4-BE49-F238E27FC236}">
+                <a16:creationId xmlns:a16="http://schemas.microsoft.com/office/drawing/2014/main" id="{25726873-305B-2BD9-5572-EA6B4B8E3D3F}"/>
+              </a:ext>
+            </a:extLst>
+          </p:cNvPr>
+          <p:cNvSpPr>
+            <a:spLocks noGrp="1"/>
+          </p:cNvSpPr>
+          <p:nvPr>
+            <p:ph type="body" sz="quarter" idx="11" hasCustomPrompt="1"/>
+          </p:nvPr>
+        </p:nvSpPr>
+        <p:spPr>
+          <a:xfrm>
+            <a:off x="2125842" y="4459075"/>
+            <a:ext cx="3745486" cy="380402"/>
+          </a:xfrm>
+        </p:spPr>
+        <p:txBody>
+          <a:bodyPr anchor="ctr">
+            <a:normAutofit/>
+          </a:bodyPr>
+          <a:lstStyle>
+            <a:lvl1pPr>
+              <a:buNone/>
               <a:defRPr sz="1800"/>
             </a:lvl1pPr>
             <a:lvl2pPr>
@@ -1275,8 +1282,8 @@
         </p:nvSpPr>
         <p:spPr>
           <a:xfrm>
-            <a:off x="282805" y="4050434"/>
-            <a:ext cx="1618365" cy="523220"/>
+            <a:off x="185492" y="3742832"/>
+            <a:ext cx="1987955" cy="707886"/>
           </a:xfrm>
           <a:prstGeom prst="rect">
             <a:avLst/>
@@ -1290,10 +1297,10 @@
           <a:lstStyle/>
           <a:p>
             <a:r>
-              <a:rPr lang="es-CL" sz="2800" dirty="0"/>
+              <a:rPr lang="es-CL" sz="4000" dirty="0"/>
               <a:t>Unidad:</a:t>
             </a:r>
-            <a:endParaRPr lang="es-CL" dirty="0"/>
+            <a:endParaRPr lang="es-CL" sz="2800" dirty="0"/>
           </a:p>
         </p:txBody>
       </p:sp>
@@ -1311,7 +1318,7 @@
         </p:nvSpPr>
         <p:spPr>
           <a:xfrm>
-            <a:off x="282805" y="4799080"/>
+            <a:off x="185492" y="4459075"/>
             <a:ext cx="1618365" cy="369332"/>
           </a:xfrm>
           <a:prstGeom prst="rect">
@@ -1431,7 +1438,7 @@
           <a:lstStyle>
             <a:lvl1pPr>
               <a:buNone/>
-              <a:defRPr sz="1800"/>
+              <a:defRPr sz="2400" b="1"/>
             </a:lvl1pPr>
             <a:lvl2pPr>
               <a:buNone/>
@@ -1474,7 +1481,7 @@
         <p:spPr>
           <a:xfrm>
             <a:off x="282805" y="6192551"/>
-            <a:ext cx="1618365" cy="369332"/>
+            <a:ext cx="1618365" cy="461665"/>
           </a:xfrm>
           <a:prstGeom prst="rect">
             <a:avLst/>
@@ -1488,10 +1495,10 @@
           <a:lstStyle/>
           <a:p>
             <a:r>
-              <a:rPr lang="es-CL" sz="1800" dirty="0"/>
+              <a:rPr lang="es-CL" sz="2400" dirty="0"/>
               <a:t>CURSO:</a:t>
             </a:r>
-            <a:endParaRPr lang="es-CL" sz="1200" dirty="0"/>
+            <a:endParaRPr lang="es-CL" sz="1600" dirty="0"/>
           </a:p>
         </p:txBody>
       </p:sp>
@@ -1524,7 +1531,7 @@
           <a:lstStyle>
             <a:lvl1pPr algn="ctr">
               <a:buNone/>
-              <a:defRPr sz="1800"/>
+              <a:defRPr sz="2000" b="1" cap="all" baseline="0"/>
             </a:lvl1pPr>
             <a:lvl2pPr>
               <a:buNone/>
@@ -1638,7 +1645,7 @@
           <a:lstStyle>
             <a:lvl1pPr>
               <a:buNone/>
-              <a:defRPr sz="5400">
+              <a:defRPr sz="5400" cap="all" baseline="0">
                 <a:latin typeface="+mj-lt"/>
               </a:defRPr>
             </a:lvl1pPr>
@@ -1897,7 +1904,7 @@
           <a:p>
             <a:fld id="{F2AF14CB-E566-41C7-9348-948E9EF6BE02}" type="datetimeFigureOut">
               <a:rPr lang="es-CL" smtClean="0"/>
-              <a:t>24-07-2026</a:t>
+              <a:t>25-07-2026</a:t>
             </a:fld>
             <a:endParaRPr lang="es-CL"/>
           </a:p>
@@ -2097,7 +2104,7 @@
           <a:p>
             <a:fld id="{F2AF14CB-E566-41C7-9348-948E9EF6BE02}" type="datetimeFigureOut">
               <a:rPr lang="es-CL" smtClean="0"/>
-              <a:t>24-07-2026</a:t>
+              <a:t>25-07-2026</a:t>
             </a:fld>
             <a:endParaRPr lang="es-CL"/>
           </a:p>
@@ -2307,7 +2314,7 @@
           <a:p>
             <a:fld id="{F2AF14CB-E566-41C7-9348-948E9EF6BE02}" type="datetimeFigureOut">
               <a:rPr lang="es-CL" smtClean="0"/>
-              <a:t>24-07-2026</a:t>
+              <a:t>25-07-2026</a:t>
             </a:fld>
             <a:endParaRPr lang="es-CL"/>
           </a:p>
@@ -2996,7 +3003,7 @@
           <a:p>
             <a:fld id="{F2AF14CB-E566-41C7-9348-948E9EF6BE02}" type="datetimeFigureOut">
               <a:rPr lang="es-CL" smtClean="0"/>
-              <a:t>24-07-2026</a:t>
+              <a:t>25-07-2026</a:t>
             </a:fld>
             <a:endParaRPr lang="es-CL"/>
           </a:p>
@@ -3264,7 +3271,7 @@
           <a:p>
             <a:fld id="{F2AF14CB-E566-41C7-9348-948E9EF6BE02}" type="datetimeFigureOut">
               <a:rPr lang="es-CL" smtClean="0"/>
-              <a:t>24-07-2026</a:t>
+              <a:t>25-07-2026</a:t>
             </a:fld>
             <a:endParaRPr lang="es-CL"/>
           </a:p>
@@ -3679,7 +3686,7 @@
           <a:p>
             <a:fld id="{F2AF14CB-E566-41C7-9348-948E9EF6BE02}" type="datetimeFigureOut">
               <a:rPr lang="es-CL" smtClean="0"/>
-              <a:t>24-07-2026</a:t>
+              <a:t>25-07-2026</a:t>
             </a:fld>
             <a:endParaRPr lang="es-CL"/>
           </a:p>
@@ -3821,7 +3828,7 @@
           <a:p>
             <a:fld id="{F2AF14CB-E566-41C7-9348-948E9EF6BE02}" type="datetimeFigureOut">
               <a:rPr lang="es-CL" smtClean="0"/>
-              <a:t>24-07-2026</a:t>
+              <a:t>25-07-2026</a:t>
             </a:fld>
             <a:endParaRPr lang="es-CL"/>
           </a:p>
@@ -3934,7 +3941,7 @@
           <a:p>
             <a:fld id="{F2AF14CB-E566-41C7-9348-948E9EF6BE02}" type="datetimeFigureOut">
               <a:rPr lang="es-CL" smtClean="0"/>
-              <a:t>24-07-2026</a:t>
+              <a:t>25-07-2026</a:t>
             </a:fld>
             <a:endParaRPr lang="es-CL"/>
           </a:p>
@@ -4247,7 +4254,7 @@
           <a:p>
             <a:fld id="{F2AF14CB-E566-41C7-9348-948E9EF6BE02}" type="datetimeFigureOut">
               <a:rPr lang="es-CL" smtClean="0"/>
-              <a:t>24-07-2026</a:t>
+              <a:t>25-07-2026</a:t>
             </a:fld>
             <a:endParaRPr lang="es-CL"/>
           </a:p>
@@ -4490,7 +4497,7 @@
           <a:p>
             <a:fld id="{F2AF14CB-E566-41C7-9348-948E9EF6BE02}" type="datetimeFigureOut">
               <a:rPr lang="es-CL" smtClean="0"/>
-              <a:t>24-07-2026</a:t>
+              <a:t>25-07-2026</a:t>
             </a:fld>
             <a:endParaRPr lang="es-CL"/>
           </a:p>
@@ -5007,7 +5014,9 @@
         </p:nvSpPr>
         <p:spPr/>
         <p:txBody>
-          <a:bodyPr/>
+          <a:bodyPr>
+            <a:normAutofit fontScale="92500" lnSpcReduction="10000"/>
+          </a:bodyPr>
           <a:lstStyle/>
           <a:p>
             <a:r>
@@ -5074,7 +5083,7 @@
           <a:lstStyle/>
           <a:p>
             <a:r>
-              <a:rPr lang="es-CL" dirty="0"/>
+              <a:rPr lang="es-CL" cap="all" dirty="0"/>
               <a:t>{{ASIGNATURA}}</a:t>
             </a:r>
           </a:p>
@@ -5156,8 +5165,8 @@
         </p:nvSpPr>
         <p:spPr>
           <a:xfrm>
-            <a:off x="838200" y="1825625"/>
-            <a:ext cx="5257800" cy="2275035"/>
+            <a:off x="838199" y="1825626"/>
+            <a:ext cx="10911647" cy="1748848"/>
           </a:xfrm>
           <a:prstGeom prst="roundRect">
             <a:avLst>
@@ -5234,8 +5243,8 @@
         </p:nvSpPr>
         <p:spPr>
           <a:xfrm>
-            <a:off x="6488786" y="1835052"/>
-            <a:ext cx="5261061" cy="4473052"/>
+            <a:off x="6488786" y="3807228"/>
+            <a:ext cx="5261061" cy="2500875"/>
           </a:xfrm>
           <a:prstGeom prst="roundRect">
             <a:avLst>
@@ -5441,15 +5450,12 @@
               <a:rPr lang="es-CL" b="1" dirty="0">
                 <a:latin typeface="Aptos Black" panose="020B0004020202020204" pitchFamily="34" charset="0"/>
               </a:rPr>
-              <a:t>UNIDAD</a:t>
-            </a:r>
-          </a:p>
-          <a:p>
-            <a:pPr marL="0" indent="0">
-              <a:buNone/>
-            </a:pPr>
-            <a:r>
-              <a:rPr lang="es-CL" sz="2400" b="1" dirty="0"/>
+              <a:t>CONTENIDOS</a:t>
+            </a:r>
+          </a:p>
+          <a:p>
+            <a:r>
+              <a:rPr lang="es-CL" sz="2000" dirty="0"/>
               <a:t>{{CONTENIDOS}}</a:t>
             </a:r>
           </a:p>
@@ -5458,33 +5464,6 @@
               <a:buFont typeface="Arial" panose="020B0604020202020204" pitchFamily="34" charset="0"/>
               <a:buNone/>
             </a:pPr>
-            <a:endParaRPr lang="es-CL" b="1" dirty="0">
-              <a:latin typeface="Aptos Black" panose="020B0004020202020204" pitchFamily="34" charset="0"/>
-            </a:endParaRPr>
-          </a:p>
-          <a:p>
-            <a:pPr marL="0" indent="0">
-              <a:buFont typeface="Arial" panose="020B0604020202020204" pitchFamily="34" charset="0"/>
-              <a:buNone/>
-            </a:pPr>
-            <a:r>
-              <a:rPr lang="es-CL" b="1" dirty="0">
-                <a:latin typeface="Aptos Black" panose="020B0004020202020204" pitchFamily="34" charset="0"/>
-              </a:rPr>
-              <a:t>CONTENIDOS</a:t>
-            </a:r>
-          </a:p>
-          <a:p>
-            <a:r>
-              <a:rPr lang="es-CL" sz="2000" dirty="0"/>
-              <a:t>{{CONTENIDOS}}</a:t>
-            </a:r>
-          </a:p>
-          <a:p>
-            <a:pPr marL="0" indent="0">
-              <a:buFont typeface="Arial" panose="020B0604020202020204" pitchFamily="34" charset="0"/>
-              <a:buNone/>
-            </a:pPr>
             <a:endParaRPr lang="es-CL" dirty="0"/>
           </a:p>
         </p:txBody>
@@ -5505,8 +5484,8 @@
         </p:nvSpPr>
         <p:spPr>
           <a:xfrm>
-            <a:off x="838200" y="4231032"/>
-            <a:ext cx="5257800" cy="2077072"/>
+            <a:off x="838200" y="3807228"/>
+            <a:ext cx="5257800" cy="2500876"/>
           </a:xfrm>
           <a:prstGeom prst="roundRect">
             <a:avLst>

</xml_diff>